<commit_message>
Unify TF diagram colors by role (navy = Biz, charcoal = Tech)
Co-Authored-By: Claude Opus 5.5 <noreply@anthropic.com>
Claude-Session: https://claude.ai/code/session_014bmYQ2fMPYk9mSnunBW5W4
</commit_message>
<xml_diff>
--- a/FDE_공동TF_조직안_우측삽입용.pptx
+++ b/FDE_공동TF_조직안_우측삽입용.pptx
@@ -972,7 +972,7 @@
             <a:avLst/>
           </a:prstGeom>
           <a:solidFill>
-            <a:srgbClr val="B0B0B0"/>
+            <a:srgbClr val="7F7F7F"/>
           </a:solidFill>
           <a:ln/>
         </p:spPr>
@@ -1024,7 +1024,7 @@
             <a:avLst/>
           </a:prstGeom>
           <a:solidFill>
-            <a:srgbClr val="999999"/>
+            <a:srgbClr val="7F7F7F"/>
           </a:solidFill>
           <a:ln/>
         </p:spPr>
@@ -1076,7 +1076,7 @@
             <a:avLst/>
           </a:prstGeom>
           <a:solidFill>
-            <a:srgbClr val="808080"/>
+            <a:srgbClr val="7F7F7F"/>
           </a:solidFill>
           <a:ln/>
         </p:spPr>
@@ -1128,7 +1128,7 @@
             <a:avLst/>
           </a:prstGeom>
           <a:solidFill>
-            <a:srgbClr val="666666"/>
+            <a:srgbClr val="7F7F7F"/>
           </a:solidFill>
           <a:ln/>
         </p:spPr>
@@ -1167,7 +1167,7 @@
       </p:sp>
       <p:sp>
         <p:nvSpPr>
-          <p:cNvPr id="8" name="VC 영업·마케팅"/>
+          <p:cNvPr id="8" name="VC 영업·MK"/>
           <p:cNvSpPr txBox="1"/>
           <p:nvPr/>
         </p:nvSpPr>
@@ -1180,7 +1180,7 @@
             <a:avLst/>
           </a:prstGeom>
           <a:solidFill>
-            <a:srgbClr val="4D4D4D"/>
+            <a:srgbClr val="7F7F7F"/>
           </a:solidFill>
           <a:ln/>
         </p:spPr>
@@ -1192,14 +1192,14 @@
               <a:buNone/>
             </a:pPr>
             <a:r>
-              <a:rPr lang="en-US" sz="700" b="1" dirty="0">
+              <a:rPr lang="en-US" sz="800" b="1" dirty="0">
                 <a:solidFill>
                   <a:srgbClr val="FFFFFF"/>
                 </a:solidFill>
               </a:rPr>
-              <a:t>영업·마케팅</a:t>
-            </a:r>
-            <a:endParaRPr lang="en-US" sz="700" dirty="0"/>
+              <a:t>영업·MK</a:t>
+            </a:r>
+            <a:endParaRPr lang="en-US" sz="800" dirty="0"/>
           </a:p>
           <a:p>
             <a:pPr algn="ctr" indent="0" marL="0">
@@ -1213,7 +1213,7 @@
               </a:rPr>
               <a:t>40건</a:t>
             </a:r>
-            <a:endParaRPr lang="en-US" sz="700" dirty="0"/>
+            <a:endParaRPr lang="en-US" sz="800" dirty="0"/>
           </a:p>
         </p:txBody>
       </p:sp>
@@ -1232,7 +1232,7 @@
             <a:avLst/>
           </a:prstGeom>
           <a:solidFill>
-            <a:srgbClr val="333F50"/>
+            <a:srgbClr val="7F7F7F"/>
           </a:solidFill>
           <a:ln/>
         </p:spPr>
@@ -1423,7 +1423,7 @@
                   <a:srgbClr val="595959"/>
                 </a:solidFill>
               </a:rPr>
-              <a:t>엔지니어 협업</a:t>
+              <a:t>Tech 조직</a:t>
             </a:r>
             <a:endParaRPr lang="en-US" sz="750" dirty="0"/>
           </a:p>
@@ -1446,7 +1446,7 @@
             </a:avLst>
           </a:prstGeom>
           <a:solidFill>
-            <a:srgbClr val="A6A6A6"/>
+            <a:srgbClr val="404040"/>
           </a:solidFill>
           <a:ln/>
           <a:effectLst>
@@ -1507,7 +1507,7 @@
             </a:avLst>
           </a:prstGeom>
           <a:solidFill>
-            <a:srgbClr val="4D4D4D"/>
+            <a:srgbClr val="404040"/>
           </a:solidFill>
           <a:ln/>
           <a:effectLst>
@@ -1568,7 +1568,7 @@
             </a:avLst>
           </a:prstGeom>
           <a:solidFill>
-            <a:srgbClr val="2E5C8A"/>
+            <a:srgbClr val="404040"/>
           </a:solidFill>
           <a:ln/>
           <a:effectLst>
@@ -1953,7 +1953,7 @@
             <a:avLst/>
           </a:prstGeom>
           <a:solidFill>
-            <a:srgbClr val="A6A6A6"/>
+            <a:srgbClr val="DCE6F1"/>
           </a:solidFill>
           <a:ln/>
         </p:spPr>
@@ -1967,7 +1967,7 @@
             <a:r>
               <a:rPr lang="en-US" sz="700" b="1" dirty="0">
                 <a:solidFill>
-                  <a:srgbClr val="FFFFFF"/>
+                  <a:srgbClr val="2E5C8A"/>
                 </a:solidFill>
               </a:rPr>
               <a:t>진단/발굴 9</a:t>
@@ -1991,7 +1991,7 @@
             <a:avLst/>
           </a:prstGeom>
           <a:solidFill>
-            <a:srgbClr val="A6A6A6"/>
+            <a:srgbClr val="DCE6F1"/>
           </a:solidFill>
           <a:ln/>
         </p:spPr>
@@ -2005,7 +2005,7 @@
             <a:r>
               <a:rPr lang="en-US" sz="700" b="1" dirty="0">
                 <a:solidFill>
-                  <a:srgbClr val="FFFFFF"/>
+                  <a:srgbClr val="2E5C8A"/>
                 </a:solidFill>
               </a:rPr>
               <a:t>전략수립 4</a:t>
@@ -2029,7 +2029,7 @@
             <a:avLst/>
           </a:prstGeom>
           <a:solidFill>
-            <a:srgbClr val="A6A6A6"/>
+            <a:srgbClr val="DCE6F1"/>
           </a:solidFill>
           <a:ln/>
         </p:spPr>
@@ -2043,10 +2043,10 @@
             <a:r>
               <a:rPr lang="en-US" sz="700" b="1" dirty="0">
                 <a:solidFill>
-                  <a:srgbClr val="FFFFFF"/>
-                </a:solidFill>
-              </a:rPr>
-              <a:t>특화영역 3</a:t>
+                  <a:srgbClr val="2E5C8A"/>
+                </a:solidFill>
+              </a:rPr>
+              <a:t>전문영역 3</a:t>
             </a:r>
             <a:endParaRPr lang="en-US" sz="700" dirty="0"/>
           </a:p>
@@ -2067,7 +2067,7 @@
             <a:avLst/>
           </a:prstGeom>
           <a:solidFill>
-            <a:srgbClr val="A6A6A6"/>
+            <a:srgbClr val="DCE6F1"/>
           </a:solidFill>
           <a:ln/>
         </p:spPr>
@@ -2081,7 +2081,7 @@
             <a:r>
               <a:rPr lang="en-US" sz="700" b="1" dirty="0">
                 <a:solidFill>
-                  <a:srgbClr val="FFFFFF"/>
+                  <a:srgbClr val="2E5C8A"/>
                 </a:solidFill>
               </a:rPr>
               <a:t>AX교육 6</a:t>
@@ -2105,7 +2105,7 @@
             <a:avLst/>
           </a:prstGeom>
           <a:solidFill>
-            <a:srgbClr val="D9D9D9"/>
+            <a:srgbClr val="DCE6F1"/>
           </a:solidFill>
           <a:ln/>
         </p:spPr>
@@ -2119,7 +2119,7 @@
             <a:r>
               <a:rPr lang="en-US" sz="700" b="1" dirty="0">
                 <a:solidFill>
-                  <a:srgbClr val="262626"/>
+                  <a:srgbClr val="2E5C8A"/>
                 </a:solidFill>
               </a:rPr>
               <a:t>그룹사 AI컨설팅 경험</a:t>
@@ -2181,7 +2181,7 @@
             <a:avLst/>
           </a:prstGeom>
           <a:solidFill>
-            <a:srgbClr val="404040"/>
+            <a:srgbClr val="2E5C8A"/>
           </a:solidFill>
           <a:ln/>
         </p:spPr>
@@ -2219,7 +2219,7 @@
             <a:avLst/>
           </a:prstGeom>
           <a:solidFill>
-            <a:srgbClr val="595959"/>
+            <a:srgbClr val="DCE6F1"/>
           </a:solidFill>
           <a:ln/>
         </p:spPr>
@@ -2233,10 +2233,10 @@
             <a:r>
               <a:rPr lang="en-US" sz="700" b="1" dirty="0">
                 <a:solidFill>
-                  <a:srgbClr val="FFFFFF"/>
-                </a:solidFill>
-              </a:rPr>
-              <a:t>식품/제조</a:t>
+                  <a:srgbClr val="2E5C8A"/>
+                </a:solidFill>
+              </a:rPr>
+              <a:t>식품·제조</a:t>
             </a:r>
             <a:endParaRPr lang="en-US" sz="700" dirty="0"/>
           </a:p>
@@ -2257,7 +2257,7 @@
             <a:avLst/>
           </a:prstGeom>
           <a:solidFill>
-            <a:srgbClr val="595959"/>
+            <a:srgbClr val="DCE6F1"/>
           </a:solidFill>
           <a:ln/>
         </p:spPr>
@@ -2271,7 +2271,7 @@
             <a:r>
               <a:rPr lang="en-US" sz="700" b="1" dirty="0">
                 <a:solidFill>
-                  <a:srgbClr val="FFFFFF"/>
+                  <a:srgbClr val="2E5C8A"/>
                 </a:solidFill>
               </a:rPr>
               <a:t>유통</a:t>
@@ -2295,7 +2295,7 @@
             <a:avLst/>
           </a:prstGeom>
           <a:solidFill>
-            <a:srgbClr val="595959"/>
+            <a:srgbClr val="DCE6F1"/>
           </a:solidFill>
           <a:ln/>
         </p:spPr>
@@ -2309,10 +2309,10 @@
             <a:r>
               <a:rPr lang="en-US" sz="700" b="1" dirty="0">
                 <a:solidFill>
-                  <a:srgbClr val="FFFFFF"/>
-                </a:solidFill>
-              </a:rPr>
-              <a:t>화학/건설</a:t>
+                  <a:srgbClr val="2E5C8A"/>
+                </a:solidFill>
+              </a:rPr>
+              <a:t>화학·건설</a:t>
             </a:r>
             <a:endParaRPr lang="en-US" sz="700" dirty="0"/>
           </a:p>
@@ -2333,7 +2333,7 @@
             <a:avLst/>
           </a:prstGeom>
           <a:solidFill>
-            <a:srgbClr val="595959"/>
+            <a:srgbClr val="DCE6F1"/>
           </a:solidFill>
           <a:ln/>
         </p:spPr>
@@ -2347,10 +2347,10 @@
             <a:r>
               <a:rPr lang="en-US" sz="700" b="1" dirty="0">
                 <a:solidFill>
-                  <a:srgbClr val="FFFFFF"/>
-                </a:solidFill>
-              </a:rPr>
-              <a:t>호텔/서비스</a:t>
+                  <a:srgbClr val="2E5C8A"/>
+                </a:solidFill>
+              </a:rPr>
+              <a:t>서비스</a:t>
             </a:r>
             <a:endParaRPr lang="en-US" sz="700" dirty="0"/>
           </a:p>
@@ -2371,7 +2371,7 @@
             <a:avLst/>
           </a:prstGeom>
           <a:solidFill>
-            <a:srgbClr val="D9D9D9"/>
+            <a:srgbClr val="DCE6F1"/>
           </a:solidFill>
           <a:ln/>
         </p:spPr>
@@ -2385,7 +2385,7 @@
             <a:r>
               <a:rPr lang="en-US" sz="700" b="1" dirty="0">
                 <a:solidFill>
-                  <a:srgbClr val="262626"/>
+                  <a:srgbClr val="2E5C8A"/>
                 </a:solidFill>
               </a:rPr>
               <a:t>차세대 PI/ISP 경험</a:t>
@@ -2447,9 +2447,13 @@
             <a:avLst/>
           </a:prstGeom>
           <a:solidFill>
-            <a:srgbClr val="404040"/>
-          </a:solidFill>
-          <a:ln/>
+            <a:srgbClr val="FFFFFF"/>
+          </a:solidFill>
+          <a:ln w="12700">
+            <a:solidFill>
+              <a:srgbClr val="2E5C8A"/>
+            </a:solidFill>
+          </a:ln>
         </p:spPr>
         <p:txBody>
           <a:bodyPr wrap="square" lIns="0" tIns="0" rIns="0" bIns="0" rtlCol="0" anchor="ctr"/>
@@ -2461,7 +2465,7 @@
             <a:r>
               <a:rPr lang="en-US" sz="750" b="1" dirty="0">
                 <a:solidFill>
-                  <a:srgbClr val="FFFFFF"/>
+                  <a:srgbClr val="2E5C8A"/>
                 </a:solidFill>
               </a:rPr>
               <a:t>FDE 공동 TF : Target 선정 → 적용 설계 → 성과 관리</a:t>
@@ -2521,16 +2525,13 @@
             <a:avLst/>
           </a:prstGeom>
           <a:solidFill>
-            <a:srgbClr val="A6A6A6"/>
-          </a:solidFill>
-          <a:ln/>
-          <a:effectLst>
-            <a:outerShdw sx="100000" sy="100000" kx="0" ky="0" algn="bl" rotWithShape="0" blurRad="19050" dist="12700" dir="5400000">
-              <a:srgbClr val="999999">
-                <a:alpha val="35000"/>
-              </a:srgbClr>
-            </a:outerShdw>
-          </a:effectLst>
+            <a:srgbClr val="FFFFFF"/>
+          </a:solidFill>
+          <a:ln w="15875">
+            <a:solidFill>
+              <a:srgbClr val="2E5C8A"/>
+            </a:solidFill>
+          </a:ln>
         </p:spPr>
         <p:txBody>
           <a:bodyPr wrap="square" lIns="0" tIns="0" rIns="0" bIns="0" rtlCol="0" anchor="ctr"/>
@@ -2542,7 +2543,7 @@
             <a:r>
               <a:rPr lang="en-US" sz="800" b="1" dirty="0">
                 <a:solidFill>
-                  <a:srgbClr val="FFFFFF"/>
+                  <a:srgbClr val="2E5C8A"/>
                 </a:solidFill>
               </a:rPr>
               <a:t>AX 진단 · 과제 발굴</a:t>
@@ -2604,7 +2605,7 @@
           <a:noFill/>
           <a:ln w="15875">
             <a:solidFill>
-              <a:srgbClr val="A6A6A6"/>
+              <a:srgbClr val="2E5C8A"/>
             </a:solidFill>
             <a:prstDash val="solid"/>
             <a:tailEnd type="triangle"/>
@@ -2626,16 +2627,13 @@
             <a:avLst/>
           </a:prstGeom>
           <a:solidFill>
-            <a:srgbClr val="4A79A8"/>
-          </a:solidFill>
-          <a:ln/>
-          <a:effectLst>
-            <a:outerShdw sx="100000" sy="100000" kx="0" ky="0" algn="bl" rotWithShape="0" blurRad="19050" dist="12700" dir="5400000">
-              <a:srgbClr val="999999">
-                <a:alpha val="35000"/>
-              </a:srgbClr>
-            </a:outerShdw>
-          </a:effectLst>
+            <a:srgbClr val="FFFFFF"/>
+          </a:solidFill>
+          <a:ln w="15875">
+            <a:solidFill>
+              <a:srgbClr val="2E5C8A"/>
+            </a:solidFill>
+          </a:ln>
         </p:spPr>
         <p:txBody>
           <a:bodyPr wrap="square" lIns="0" tIns="0" rIns="0" bIns="0" rtlCol="0" anchor="ctr"/>
@@ -2647,7 +2645,7 @@
             <a:r>
               <a:rPr lang="en-US" sz="800" b="1" dirty="0">
                 <a:solidFill>
-                  <a:srgbClr val="FFFFFF"/>
+                  <a:srgbClr val="2E5C8A"/>
                 </a:solidFill>
               </a:rPr>
               <a:t>MVP 구축 · 검증</a:t>
@@ -2709,7 +2707,7 @@
           <a:noFill/>
           <a:ln w="15875">
             <a:solidFill>
-              <a:srgbClr val="4A79A8"/>
+              <a:srgbClr val="2E5C8A"/>
             </a:solidFill>
             <a:prstDash val="solid"/>
             <a:tailEnd type="triangle"/>
@@ -2731,16 +2729,13 @@
             <a:avLst/>
           </a:prstGeom>
           <a:solidFill>
-            <a:srgbClr val="2E5C8A"/>
-          </a:solidFill>
-          <a:ln/>
-          <a:effectLst>
-            <a:outerShdw sx="100000" sy="100000" kx="0" ky="0" algn="bl" rotWithShape="0" blurRad="19050" dist="12700" dir="5400000">
-              <a:srgbClr val="999999">
-                <a:alpha val="35000"/>
-              </a:srgbClr>
-            </a:outerShdw>
-          </a:effectLst>
+            <a:srgbClr val="FFFFFF"/>
+          </a:solidFill>
+          <a:ln w="15875">
+            <a:solidFill>
+              <a:srgbClr val="2E5C8A"/>
+            </a:solidFill>
+          </a:ln>
         </p:spPr>
         <p:txBody>
           <a:bodyPr wrap="square" lIns="0" tIns="0" rIns="0" bIns="0" rtlCol="0" anchor="ctr"/>
@@ -2752,7 +2747,7 @@
             <a:r>
               <a:rPr lang="en-US" sz="800" b="1" dirty="0">
                 <a:solidFill>
-                  <a:srgbClr val="FFFFFF"/>
+                  <a:srgbClr val="2E5C8A"/>
                 </a:solidFill>
               </a:rPr>
               <a:t>구축 · 운영 이관</a:t>

</xml_diff>